<commit_message>
Add KPI targets and dataset justification
</commit_message>
<xml_diff>
--- a/presentations/Business_Presentation.pptx
+++ b/presentations/Business_Presentation.pptx
@@ -997,7 +997,7 @@
           <a:lstStyle/>
           <a:p>
             <a:r>
-              <a:t>The ask. Approve the pilot, adopt the safety net rule for perks, and name an owner for keeping the groups up to date. On the right are the four measures we will report back on.</a:t>
+              <a:t>The ask. Approve the pilot, adopt the safety net rule for perks, and name an owner for keeping the groups up to date. On the right are the four measures we will report back on, each with a proposed target. The 90 and 34 percent figures are what happened in the data with no special marketing: 90 percent of the top fifth of spenders bought again the following year, and 34 percent of customers who had gone quiet for six months came back on their own. The targets are proposals for discussion.</a:t>
             </a:r>
           </a:p>
         </p:txBody>
@@ -4920,7 +4920,7 @@
         <p:spPr>
           <a:xfrm>
             <a:off x="1463040" y="1801368"/>
-            <a:ext cx="5669280" cy="457200"/>
+            <a:ext cx="5394960" cy="457200"/>
           </a:xfrm>
           <a:prstGeom prst="rect">
             <a:avLst/>
@@ -4955,7 +4955,7 @@
         <p:spPr>
           <a:xfrm>
             <a:off x="1463040" y="2286000"/>
-            <a:ext cx="5669280" cy="731520"/>
+            <a:ext cx="5394960" cy="731520"/>
           </a:xfrm>
           <a:prstGeom prst="rect">
             <a:avLst/>
@@ -5043,7 +5043,7 @@
         <p:spPr>
           <a:xfrm>
             <a:off x="1463040" y="3172968"/>
-            <a:ext cx="5669280" cy="457200"/>
+            <a:ext cx="5394960" cy="457200"/>
           </a:xfrm>
           <a:prstGeom prst="rect">
             <a:avLst/>
@@ -5078,7 +5078,7 @@
         <p:spPr>
           <a:xfrm>
             <a:off x="1463040" y="3657600"/>
-            <a:ext cx="5669280" cy="731520"/>
+            <a:ext cx="5394960" cy="731520"/>
           </a:xfrm>
           <a:prstGeom prst="rect">
             <a:avLst/>
@@ -5166,7 +5166,7 @@
         <p:spPr>
           <a:xfrm>
             <a:off x="1463040" y="4544568"/>
-            <a:ext cx="5669280" cy="457200"/>
+            <a:ext cx="5394960" cy="457200"/>
           </a:xfrm>
           <a:prstGeom prst="rect">
             <a:avLst/>
@@ -5201,7 +5201,7 @@
         <p:spPr>
           <a:xfrm>
             <a:off x="1463040" y="5029200"/>
-            <a:ext cx="5669280" cy="731520"/>
+            <a:ext cx="5394960" cy="731520"/>
           </a:xfrm>
           <a:prstGeom prst="rect">
             <a:avLst/>
@@ -5235,8 +5235,8 @@
         </p:nvSpPr>
         <p:spPr>
           <a:xfrm>
-            <a:off x="7680960" y="1783080"/>
-            <a:ext cx="3867912" cy="2926080"/>
+            <a:off x="7223760" y="1783080"/>
+            <a:ext cx="4325112" cy="3429000"/>
           </a:xfrm>
           <a:prstGeom prst="roundRect">
             <a:avLst>
@@ -5281,8 +5281,8 @@
         </p:nvSpPr>
         <p:spPr>
           <a:xfrm>
-            <a:off x="7955279" y="1965960"/>
-            <a:ext cx="3383280" cy="3749039"/>
+            <a:off x="7498079" y="1965960"/>
+            <a:ext cx="3840480" cy="4023360"/>
           </a:xfrm>
           <a:prstGeom prst="rect">
             <a:avLst/>
@@ -5297,7 +5297,7 @@
           <a:p>
             <a:pPr algn="l">
               <a:spcAft>
-                <a:spcPts val="1200"/>
+                <a:spcPts val="900"/>
               </a:spcAft>
             </a:pPr>
             <a:r>
@@ -5313,65 +5313,117 @@
           <a:p>
             <a:pPr algn="l">
               <a:spcAft>
-                <a:spcPts val="1200"/>
+                <a:spcPts val="900"/>
               </a:spcAft>
             </a:pPr>
             <a:r>
+              <a:rPr sz="1500" b="1">
+                <a:solidFill>
+                  <a:srgbClr val="FFFFFF"/>
+                </a:solidFill>
+                <a:latin typeface="Calibri"/>
+              </a:rPr>
+              <a:t>Campaign response: </a:t>
+            </a:r>
+            <a:r>
               <a:rPr sz="1500" b="0">
                 <a:solidFill>
-                  <a:srgbClr val="FFFFFF"/>
+                  <a:srgbClr val="B9D3D1"/>
                 </a:solidFill>
                 <a:latin typeface="Calibri"/>
               </a:rPr>
-              <a:t>Response rate to each group's campaign</a:t>
+              <a:t>at least 20% above the control group</a:t>
             </a:r>
           </a:p>
           <a:p>
             <a:pPr algn="l">
               <a:spcAft>
-                <a:spcPts val="1200"/>
+                <a:spcPts val="900"/>
               </a:spcAft>
             </a:pPr>
             <a:r>
+              <a:rPr sz="1500" b="1">
+                <a:solidFill>
+                  <a:srgbClr val="FFFFFF"/>
+                </a:solidFill>
+                <a:latin typeface="Calibri"/>
+              </a:rPr>
+              <a:t>Top customers who reorder: </a:t>
+            </a:r>
+            <a:r>
               <a:rPr sz="1500" b="0">
                 <a:solidFill>
-                  <a:srgbClr val="FFFFFF"/>
+                  <a:srgbClr val="B9D3D1"/>
                 </a:solidFill>
                 <a:latin typeface="Calibri"/>
               </a:rPr>
-              <a:t>Repeat purchases by Loyal Regulars</a:t>
+              <a:t>from 90% today to 92%</a:t>
             </a:r>
           </a:p>
           <a:p>
             <a:pPr algn="l">
               <a:spcAft>
-                <a:spcPts val="1200"/>
+                <a:spcPts val="900"/>
               </a:spcAft>
             </a:pPr>
             <a:r>
+              <a:rPr sz="1500" b="1">
+                <a:solidFill>
+                  <a:srgbClr val="FFFFFF"/>
+                </a:solidFill>
+                <a:latin typeface="Calibri"/>
+              </a:rPr>
+              <a:t>Quiet customers won back: </a:t>
+            </a:r>
+            <a:r>
               <a:rPr sz="1500" b="0">
                 <a:solidFill>
-                  <a:srgbClr val="FFFFFF"/>
+                  <a:srgbClr val="B9D3D1"/>
                 </a:solidFill>
                 <a:latin typeface="Calibri"/>
               </a:rPr>
-              <a:t>Share of Lapsed Customers won back</a:t>
+              <a:t>from 34% today to 39%</a:t>
             </a:r>
           </a:p>
           <a:p>
             <a:pPr algn="l">
               <a:spcAft>
-                <a:spcPts val="1200"/>
+                <a:spcPts val="900"/>
               </a:spcAft>
             </a:pPr>
             <a:r>
+              <a:rPr sz="1500" b="1">
+                <a:solidFill>
+                  <a:srgbClr val="FFFFFF"/>
+                </a:solidFill>
+                <a:latin typeface="Calibri"/>
+              </a:rPr>
+              <a:t>Marketing cost per £ of sales: </a:t>
+            </a:r>
+            <a:r>
               <a:rPr sz="1500" b="0">
                 <a:solidFill>
-                  <a:srgbClr val="FFFFFF"/>
+                  <a:srgbClr val="B9D3D1"/>
                 </a:solidFill>
                 <a:latin typeface="Calibri"/>
               </a:rPr>
-              <a:t>Marketing cost per £ of sales</a:t>
+              <a:t>10% lower than today</a:t>
+            </a:r>
+          </a:p>
+          <a:p>
+            <a:pPr algn="l">
+              <a:spcAft>
+                <a:spcPts val="900"/>
+              </a:spcAft>
+            </a:pPr>
+            <a:r>
+              <a:rPr sz="1200" b="0">
+                <a:solidFill>
+                  <a:srgbClr val="B9D3D1"/>
+                </a:solidFill>
+                <a:latin typeface="Calibri"/>
+              </a:rPr>
+              <a:t>Proposed targets, to be agreed</a:t>
             </a:r>
           </a:p>
         </p:txBody>

</xml_diff>